<commit_message>
fix documentation - wrong button for outputs
</commit_message>
<xml_diff>
--- a/ToolIntegration/dummyTools/toolWrapper/documentation/toolIntegrationSettings.pptx
+++ b/ToolIntegration/dummyTools/toolWrapper/documentation/toolIntegrationSettings.pptx
@@ -248,7 +248,7 @@
           <a:p>
             <a:fld id="{CE0980D6-5DF0-463D-BFB7-BC7EA5530348}" type="datetimeFigureOut">
               <a:rPr lang="de-DE" smtClean="0"/>
-              <a:t>02.03.2025</a:t>
+              <a:t>26.05.2025</a:t>
             </a:fld>
             <a:endParaRPr lang="de-DE"/>
           </a:p>
@@ -425,7 +425,7 @@
           <a:p>
             <a:fld id="{2E535C94-B646-4D4D-A5E3-882C7E78FF5D}" type="datetimeFigureOut">
               <a:rPr lang="de-DE" smtClean="0"/>
-              <a:t>02.03.2025</a:t>
+              <a:t>26.05.2025</a:t>
             </a:fld>
             <a:endParaRPr lang="de-DE"/>
           </a:p>
@@ -35956,8 +35956,8 @@
         </p:nvSpPr>
         <p:spPr>
           <a:xfrm>
-            <a:off x="7005029" y="5580913"/>
-            <a:ext cx="1144708" cy="345444"/>
+            <a:off x="5182667" y="445536"/>
+            <a:ext cx="1475709" cy="345444"/>
           </a:xfrm>
           <a:prstGeom prst="borderCallout2">
             <a:avLst>
@@ -35965,8 +35965,8 @@
               <a:gd name="adj2" fmla="val -8333"/>
               <a:gd name="adj3" fmla="val 18750"/>
               <a:gd name="adj4" fmla="val -16667"/>
-              <a:gd name="adj5" fmla="val 201852"/>
-              <a:gd name="adj6" fmla="val -60387"/>
+              <a:gd name="adj5" fmla="val 246591"/>
+              <a:gd name="adj6" fmla="val -114932"/>
             </a:avLst>
           </a:prstGeom>
           <a:solidFill>
@@ -36018,7 +36018,7 @@
                   </a:schemeClr>
                 </a:solidFill>
               </a:rPr>
-              <a:t>(4) Next &gt;</a:t>
+              <a:t>(4) Outputs</a:t>
             </a:r>
             <a:endParaRPr lang="de-DE" sz="1600" dirty="0">
               <a:solidFill>

</xml_diff>